<commit_message>
updated presentation for better flow
</commit_message>
<xml_diff>
--- a/presentation/climate-futures-pricing-proposal.pptx
+++ b/presentation/climate-futures-pricing-proposal.pptx
@@ -11,12 +11,12 @@
     <p:sldId id="256" r:id="rId2"/>
     <p:sldId id="257" r:id="rId3"/>
     <p:sldId id="258" r:id="rId4"/>
-    <p:sldId id="259" r:id="rId5"/>
-    <p:sldId id="260" r:id="rId6"/>
-    <p:sldId id="261" r:id="rId7"/>
-    <p:sldId id="262" r:id="rId8"/>
-    <p:sldId id="263" r:id="rId9"/>
-    <p:sldId id="264" r:id="rId10"/>
+    <p:sldId id="260" r:id="rId5"/>
+    <p:sldId id="261" r:id="rId6"/>
+    <p:sldId id="262" r:id="rId7"/>
+    <p:sldId id="263" r:id="rId8"/>
+    <p:sldId id="264" r:id="rId9"/>
+    <p:sldId id="259" r:id="rId10"/>
     <p:sldId id="265" r:id="rId11"/>
     <p:sldId id="266" r:id="rId12"/>
     <p:sldId id="267" r:id="rId13"/>
@@ -2185,14 +2185,14 @@
           <a:p>
             <a:r>
               <a:rPr lang="en-US" dirty="0"/>
-              <a:t>0:45  ·  leave by 2:45
-• Traders and funds — price risk, signals
-• Food and beverage makers — procurement, hedging
-• Grain handlers, barge and rail, ports — physical disruption
-• Farmers and co-ops — hedging, marketing
-• Insurers and lenders — crop insurance, ag credit
-• Policymakers and consumers — food security, prices
-• Land this: a validated score helps everyone who does not trade</a:t>
+              <a:t>1:05  ·  leave by 3:50
+• All free and public, 15+ years of history
+• NASA POWER — daily temperature and rain, any location
+• Drought Monitor — weekly by county and state, published Thursdays → lets me test timing
+• Yahoo Finance — corn, soy, wheat, coffee, cocoa, OJ; Teucrium CORN avoids roll jumps
+• FAO yields via Our World in Data — the answer key
+• Next: NOAA Storm Events, and USDA county production (free key) for weights
+• Everything but USDA already pulled and checked</a:t>
             </a:r>
           </a:p>
         </p:txBody>
@@ -2279,14 +2279,12 @@
           <a:p>
             <a:r>
               <a:rPr lang="en-US" dirty="0"/>
-              <a:t>1:05  ·  leave by 3:50
-• All free and public, 15+ years of history
-• NASA POWER — daily temperature and rain, any location
-• Drought Monitor — weekly by county and state, published Thursdays → lets me test timing
-• Yahoo Finance — corn, soy, wheat, coffee, cocoa, OJ; Teucrium CORN avoids roll jumps
-• FAO yields via Our World in Data — the answer key
-• Next: NOAA Storm Events, and USDA county production (free key) for weights
-• Everything but USDA already pulled and checked</a:t>
+              <a:t>0:50  ·  leave by 4:40
+• Feasibility check before committing to the project
+• 5 corn-belt points, equal weights; index = July heat + summer rain + peak drought
+• r = −0.73 against yield vs trend
+• Without 2012: −0.43, still significant. July heat alone −0.78
+• Point: the measurement works even this crude</a:t>
             </a:r>
           </a:p>
         </p:txBody>
@@ -2373,12 +2371,13 @@
           <a:p>
             <a:r>
               <a:rPr lang="en-US" dirty="0"/>
-              <a:t>0:50  ·  leave by 4:40
-• Feasibility check before committing to the project
-• 5 corn-belt points, equal weights; index = July heat + summer rain + peak drought
-• r = −0.73 against yield vs trend
-• Without 2012: −0.43, still significant. July heat alone −0.78
-• Point: the measurement works even this crude</a:t>
+              <a:t>0:55  ·  leave by 5:35
+• Worst corn-belt drought in decades
+• Green = corn futures; red = share of Iowa in severe drought
+• July 3: corn +30%, but only 1% of Iowa in severe drought
+• Half the rally done by July 2 — two weeks before the map showed half the state
+• Maps publish two days after their date
+• Drought was real: yields −22% vs trend. The market did not wait for the data</a:t>
             </a:r>
           </a:p>
         </p:txBody>
@@ -2465,13 +2464,13 @@
           <a:p>
             <a:r>
               <a:rPr lang="en-US" dirty="0"/>
-              <a:t>0:55  ·  leave by 5:35
-• Worst corn-belt drought in decades
-• Green = corn futures; red = share of Iowa in severe drought
-• July 3: corn +30%, but only 1% of Iowa in severe drought
-• Half the rally done by July 2 — two weeks before the map showed half the state
-• Maps publish two days after their date
-• Drought was real: yields −22% vs trend. The market did not wait for the data</a:t>
+              <a:t>1:00  ·  leave by 6:35
+• Bars = correlation of weekly corn returns with drought change, by timing
+• Green (1–3 weeks before publication) strongest; publication week ≈ 0
+• Drought builds slowly → also estimated every lead and lag jointly
+• Still leads by 1–2 weeks, nothing after publication significant, holds without 2012
+• Annual story is almost all 2012: +0.42 → +0.07
+• So the market may already know — the project measures how early</a:t>
             </a:r>
           </a:p>
         </p:txBody>
@@ -2558,13 +2557,13 @@
           <a:p>
             <a:r>
               <a:rPr lang="en-US" dirty="0"/>
-              <a:t>1:00  ·  leave by 6:35
-• Bars = correlation of weekly corn returns with drought change, by timing
-• Green (1–3 weeks before publication) strongest; publication week ≈ 0
-• Drought builds slowly → also estimated every lead and lag jointly
-• Still leads by 1–2 weeks, nothing after publication significant, holds without 2012
-• Annual story is almost all 2012: +0.42 → +0.07
-• So the market may already know — the project measures how early</a:t>
+              <a:t>0:45  ·  leave by 7:20
+• BCG 10-20-70 — 10% algorithms, 20% data and tech, 70% people and process
+• My algorithms are deliberately simple
+• Most of the semester is the 20%: exposure, pipeline, publication dates
+• The 70% is the stakeholder slide: whose decision changes, and when
+• If the market already prices weather, that was only the 10%
+• Caveat: enterprise rule, I am one person — it guides effort, not a change programme</a:t>
             </a:r>
           </a:p>
         </p:txBody>
@@ -2651,13 +2650,14 @@
           <a:p>
             <a:r>
               <a:rPr lang="en-US" dirty="0"/>
-              <a:t>0:45  ·  leave by 7:20
-• BCG 10-20-70 — 10% algorithms, 20% data and tech, 70% people and process
-• My algorithms are deliberately simple
-• Most of the semester is the 20%: exposure, pipeline, publication dates
-• The 70% is the stakeholder slide: whose decision changes, and when
-• If the market already prices weather, that was only the 10%
-• Caveat: enterprise rule, I am one person — it guides effort, not a change programme</a:t>
+              <a:t>0:45  ·  leave by 2:45
+• Traders and funds — price risk, signals
+• Food and beverage makers — procurement, hedging
+• Grain handlers, barge and rail, ports — physical disruption
+• Farmers and co-ops — hedging, marketing
+• Insurers and lenders — crop insurance, ag credit
+• Policymakers and consumers — food security, prices
+• Land this: a validated score helps everyone who does not trade</a:t>
             </a:r>
           </a:p>
         </p:txBody>
@@ -3203,7 +3203,7 @@
                 <a:ea typeface="Georgia" pitchFamily="34" charset="-122"/>
                 <a:cs typeface="Georgia" pitchFamily="34" charset="-120"/>
               </a:rPr>
-              <a:t>Climate Futures Pricing</a:t>
+              <a:t>Climate Impacts on Futures Pricing</a:t>
             </a:r>
             <a:endParaRPr lang="en-US" sz="5400" dirty="0"/>
           </a:p>
@@ -10061,1204 +10061,6 @@
 </file>
 
 <file path=ppt/slides/slide4.xml><?xml version="1.0" encoding="utf-8"?>
-<p:sld xmlns:a="http://schemas.openxmlformats.org/drawingml/2006/main" xmlns:r="http://schemas.openxmlformats.org/officeDocument/2006/relationships" xmlns:p="http://schemas.openxmlformats.org/presentationml/2006/main">
-  <p:cSld name="Slide 4">
-    <p:spTree>
-      <p:nvGrpSpPr>
-        <p:cNvPr id="1" name=""/>
-        <p:cNvGrpSpPr/>
-        <p:nvPr/>
-      </p:nvGrpSpPr>
-      <p:grpSpPr>
-        <a:xfrm>
-          <a:off x="0" y="0"/>
-          <a:ext cx="0" cy="0"/>
-          <a:chOff x="0" y="0"/>
-          <a:chExt cx="0" cy="0"/>
-        </a:xfrm>
-      </p:grpSpPr>
-      <p:sp>
-        <p:nvSpPr>
-          <p:cNvPr id="2" name="Text 0"/>
-          <p:cNvSpPr txBox="1"/>
-          <p:nvPr/>
-        </p:nvSpPr>
-        <p:spPr>
-          <a:xfrm>
-            <a:off x="548640" y="384048"/>
-            <a:ext cx="11094415" cy="658368"/>
-          </a:xfrm>
-          <a:prstGeom prst="rect">
-            <a:avLst/>
-          </a:prstGeom>
-          <a:noFill/>
-          <a:ln/>
-        </p:spPr>
-        <p:txBody>
-          <a:bodyPr wrap="square" lIns="0" tIns="0" rIns="0" bIns="0" rtlCol="0" anchor="ctr"/>
-          <a:lstStyle/>
-          <a:p>
-            <a:pPr marL="0" indent="0">
-              <a:buNone/>
-            </a:pPr>
-            <a:r>
-              <a:rPr lang="en-US" sz="3600" b="1" dirty="0">
-                <a:solidFill>
-                  <a:srgbClr val="1D2723"/>
-                </a:solidFill>
-                <a:latin typeface="Georgia" pitchFamily="34" charset="0"/>
-                <a:ea typeface="Georgia" pitchFamily="34" charset="-122"/>
-                <a:cs typeface="Georgia" pitchFamily="34" charset="-120"/>
-              </a:rPr>
-              <a:t>Stakeholders</a:t>
-            </a:r>
-            <a:endParaRPr lang="en-US" sz="3600" dirty="0"/>
-          </a:p>
-        </p:txBody>
-      </p:sp>
-      <p:sp>
-        <p:nvSpPr>
-          <p:cNvPr id="3" name="Text 1"/>
-          <p:cNvSpPr txBox="1"/>
-          <p:nvPr/>
-        </p:nvSpPr>
-        <p:spPr>
-          <a:xfrm>
-            <a:off x="548640" y="1042416"/>
-            <a:ext cx="11094415" cy="402336"/>
-          </a:xfrm>
-          <a:prstGeom prst="rect">
-            <a:avLst/>
-          </a:prstGeom>
-          <a:noFill/>
-          <a:ln/>
-        </p:spPr>
-        <p:txBody>
-          <a:bodyPr wrap="square" lIns="0" tIns="0" rIns="0" bIns="0" rtlCol="0" anchor="ctr"/>
-          <a:lstStyle/>
-          <a:p>
-            <a:pPr marL="0" indent="0">
-              <a:buNone/>
-            </a:pPr>
-            <a:r>
-              <a:rPr lang="en-US" sz="1800" dirty="0">
-                <a:solidFill>
-                  <a:srgbClr val="5E6A64"/>
-                </a:solidFill>
-                <a:latin typeface="Arial" pitchFamily="34" charset="0"/>
-                <a:ea typeface="Arial" pitchFamily="34" charset="-122"/>
-                <a:cs typeface="Arial" pitchFamily="34" charset="-120"/>
-              </a:rPr>
-              <a:t>Who needs to know when weather becomes a supply shock</a:t>
-            </a:r>
-            <a:endParaRPr lang="en-US" sz="1800" dirty="0"/>
-          </a:p>
-        </p:txBody>
-      </p:sp>
-      <p:sp>
-        <p:nvSpPr>
-          <p:cNvPr id="4" name="Shape 2"/>
-          <p:cNvSpPr/>
-          <p:nvPr/>
-        </p:nvSpPr>
-        <p:spPr>
-          <a:xfrm>
-            <a:off x="548640" y="1737360"/>
-            <a:ext cx="3515258" cy="1874520"/>
-          </a:xfrm>
-          <a:prstGeom prst="roundRect">
-            <a:avLst>
-              <a:gd name="adj" fmla="val 3902"/>
-            </a:avLst>
-          </a:prstGeom>
-          <a:solidFill>
-            <a:srgbClr val="F2F5F3"/>
-          </a:solidFill>
-          <a:ln w="9525">
-            <a:solidFill>
-              <a:srgbClr val="F2F5F3"/>
-            </a:solidFill>
-            <a:prstDash val="solid"/>
-          </a:ln>
-        </p:spPr>
-        <p:txBody>
-          <a:bodyPr/>
-          <a:lstStyle/>
-          <a:p>
-            <a:endParaRPr lang="en-US"/>
-          </a:p>
-        </p:txBody>
-      </p:sp>
-      <p:sp>
-        <p:nvSpPr>
-          <p:cNvPr id="5" name="Shape 3"/>
-          <p:cNvSpPr/>
-          <p:nvPr/>
-        </p:nvSpPr>
-        <p:spPr>
-          <a:xfrm>
-            <a:off x="822960" y="2029968"/>
-            <a:ext cx="731520" cy="731520"/>
-          </a:xfrm>
-          <a:prstGeom prst="ellipse">
-            <a:avLst/>
-          </a:prstGeom>
-          <a:solidFill>
-            <a:srgbClr val="16302A"/>
-          </a:solidFill>
-          <a:ln w="9525">
-            <a:solidFill>
-              <a:srgbClr val="16302A"/>
-            </a:solidFill>
-            <a:prstDash val="solid"/>
-          </a:ln>
-        </p:spPr>
-        <p:txBody>
-          <a:bodyPr/>
-          <a:lstStyle/>
-          <a:p>
-            <a:endParaRPr lang="en-US"/>
-          </a:p>
-        </p:txBody>
-      </p:sp>
-      <p:pic>
-        <p:nvPicPr>
-          <p:cNvPr id="6" name="Image 0" descr="preencoded.png"/>
-          <p:cNvPicPr>
-            <a:picLocks noChangeAspect="1"/>
-          </p:cNvPicPr>
-          <p:nvPr/>
-        </p:nvPicPr>
-        <p:blipFill>
-          <a:blip r:embed="rId3"/>
-          <a:stretch>
-            <a:fillRect/>
-          </a:stretch>
-        </p:blipFill>
-        <p:spPr>
-          <a:xfrm>
-            <a:off x="998525" y="2205533"/>
-            <a:ext cx="380390" cy="380390"/>
-          </a:xfrm>
-          <a:prstGeom prst="rect">
-            <a:avLst/>
-          </a:prstGeom>
-        </p:spPr>
-      </p:pic>
-      <p:sp>
-        <p:nvSpPr>
-          <p:cNvPr id="7" name="Text 4"/>
-          <p:cNvSpPr txBox="1"/>
-          <p:nvPr/>
-        </p:nvSpPr>
-        <p:spPr>
-          <a:xfrm>
-            <a:off x="1737360" y="2029968"/>
-            <a:ext cx="2097938" cy="731520"/>
-          </a:xfrm>
-          <a:prstGeom prst="rect">
-            <a:avLst/>
-          </a:prstGeom>
-          <a:noFill/>
-          <a:ln/>
-        </p:spPr>
-        <p:txBody>
-          <a:bodyPr wrap="square" lIns="0" tIns="0" rIns="0" bIns="0" rtlCol="0" anchor="ctr"/>
-          <a:lstStyle/>
-          <a:p>
-            <a:pPr marL="0" indent="0">
-              <a:buNone/>
-            </a:pPr>
-            <a:r>
-              <a:rPr lang="en-US" sz="1700" b="1" dirty="0">
-                <a:solidFill>
-                  <a:srgbClr val="1D2723"/>
-                </a:solidFill>
-                <a:latin typeface="Arial" pitchFamily="34" charset="0"/>
-                <a:ea typeface="Arial" pitchFamily="34" charset="-122"/>
-                <a:cs typeface="Arial" pitchFamily="34" charset="-120"/>
-              </a:rPr>
-              <a:t>Commodity traders and funds</a:t>
-            </a:r>
-            <a:endParaRPr lang="en-US" sz="1700" dirty="0"/>
-          </a:p>
-        </p:txBody>
-      </p:sp>
-      <p:sp>
-        <p:nvSpPr>
-          <p:cNvPr id="8" name="Text 5"/>
-          <p:cNvSpPr txBox="1"/>
-          <p:nvPr/>
-        </p:nvSpPr>
-        <p:spPr>
-          <a:xfrm>
-            <a:off x="822960" y="2926080"/>
-            <a:ext cx="2966618" cy="548640"/>
-          </a:xfrm>
-          <a:prstGeom prst="rect">
-            <a:avLst/>
-          </a:prstGeom>
-          <a:noFill/>
-          <a:ln/>
-        </p:spPr>
-        <p:txBody>
-          <a:bodyPr wrap="square" lIns="0" tIns="0" rIns="0" bIns="0" rtlCol="0" anchor="t"/>
-          <a:lstStyle/>
-          <a:p>
-            <a:pPr marL="0" indent="0">
-              <a:buNone/>
-            </a:pPr>
-            <a:r>
-              <a:rPr lang="en-US" sz="1400" dirty="0">
-                <a:solidFill>
-                  <a:srgbClr val="5E6A64"/>
-                </a:solidFill>
-                <a:latin typeface="Arial" pitchFamily="34" charset="0"/>
-                <a:ea typeface="Arial" pitchFamily="34" charset="-122"/>
-                <a:cs typeface="Arial" pitchFamily="34" charset="-120"/>
-              </a:rPr>
-              <a:t>Price risk and trading signals</a:t>
-            </a:r>
-            <a:endParaRPr lang="en-US" sz="1400" dirty="0"/>
-          </a:p>
-        </p:txBody>
-      </p:sp>
-      <p:sp>
-        <p:nvSpPr>
-          <p:cNvPr id="9" name="Shape 6"/>
-          <p:cNvSpPr/>
-          <p:nvPr/>
-        </p:nvSpPr>
-        <p:spPr>
-          <a:xfrm>
-            <a:off x="4338218" y="1737360"/>
-            <a:ext cx="3515258" cy="1874520"/>
-          </a:xfrm>
-          <a:prstGeom prst="roundRect">
-            <a:avLst>
-              <a:gd name="adj" fmla="val 3902"/>
-            </a:avLst>
-          </a:prstGeom>
-          <a:solidFill>
-            <a:srgbClr val="F2F5F3"/>
-          </a:solidFill>
-          <a:ln w="9525">
-            <a:solidFill>
-              <a:srgbClr val="F2F5F3"/>
-            </a:solidFill>
-            <a:prstDash val="solid"/>
-          </a:ln>
-        </p:spPr>
-        <p:txBody>
-          <a:bodyPr/>
-          <a:lstStyle/>
-          <a:p>
-            <a:endParaRPr lang="en-US"/>
-          </a:p>
-        </p:txBody>
-      </p:sp>
-      <p:sp>
-        <p:nvSpPr>
-          <p:cNvPr id="10" name="Shape 7"/>
-          <p:cNvSpPr/>
-          <p:nvPr/>
-        </p:nvSpPr>
-        <p:spPr>
-          <a:xfrm>
-            <a:off x="4612538" y="2029968"/>
-            <a:ext cx="731520" cy="731520"/>
-          </a:xfrm>
-          <a:prstGeom prst="ellipse">
-            <a:avLst/>
-          </a:prstGeom>
-          <a:solidFill>
-            <a:srgbClr val="16302A"/>
-          </a:solidFill>
-          <a:ln w="9525">
-            <a:solidFill>
-              <a:srgbClr val="16302A"/>
-            </a:solidFill>
-            <a:prstDash val="solid"/>
-          </a:ln>
-        </p:spPr>
-        <p:txBody>
-          <a:bodyPr/>
-          <a:lstStyle/>
-          <a:p>
-            <a:endParaRPr lang="en-US"/>
-          </a:p>
-        </p:txBody>
-      </p:sp>
-      <p:pic>
-        <p:nvPicPr>
-          <p:cNvPr id="11" name="Image 1" descr="preencoded.png"/>
-          <p:cNvPicPr>
-            <a:picLocks noChangeAspect="1"/>
-          </p:cNvPicPr>
-          <p:nvPr/>
-        </p:nvPicPr>
-        <p:blipFill>
-          <a:blip r:embed="rId4"/>
-          <a:stretch>
-            <a:fillRect/>
-          </a:stretch>
-        </p:blipFill>
-        <p:spPr>
-          <a:xfrm>
-            <a:off x="4788103" y="2205533"/>
-            <a:ext cx="380390" cy="380390"/>
-          </a:xfrm>
-          <a:prstGeom prst="rect">
-            <a:avLst/>
-          </a:prstGeom>
-        </p:spPr>
-      </p:pic>
-      <p:sp>
-        <p:nvSpPr>
-          <p:cNvPr id="12" name="Text 8"/>
-          <p:cNvSpPr txBox="1"/>
-          <p:nvPr/>
-        </p:nvSpPr>
-        <p:spPr>
-          <a:xfrm>
-            <a:off x="5526938" y="2029968"/>
-            <a:ext cx="2097938" cy="731520"/>
-          </a:xfrm>
-          <a:prstGeom prst="rect">
-            <a:avLst/>
-          </a:prstGeom>
-          <a:noFill/>
-          <a:ln/>
-        </p:spPr>
-        <p:txBody>
-          <a:bodyPr wrap="square" lIns="0" tIns="0" rIns="0" bIns="0" rtlCol="0" anchor="ctr"/>
-          <a:lstStyle/>
-          <a:p>
-            <a:pPr marL="0" indent="0">
-              <a:buNone/>
-            </a:pPr>
-            <a:r>
-              <a:rPr lang="en-US" sz="1700" b="1" dirty="0">
-                <a:solidFill>
-                  <a:srgbClr val="1D2723"/>
-                </a:solidFill>
-                <a:latin typeface="Arial" pitchFamily="34" charset="0"/>
-                <a:ea typeface="Arial" pitchFamily="34" charset="-122"/>
-                <a:cs typeface="Arial" pitchFamily="34" charset="-120"/>
-              </a:rPr>
-              <a:t>Food and beverage manufacturers</a:t>
-            </a:r>
-            <a:endParaRPr lang="en-US" sz="1700" dirty="0"/>
-          </a:p>
-        </p:txBody>
-      </p:sp>
-      <p:sp>
-        <p:nvSpPr>
-          <p:cNvPr id="13" name="Text 9"/>
-          <p:cNvSpPr txBox="1"/>
-          <p:nvPr/>
-        </p:nvSpPr>
-        <p:spPr>
-          <a:xfrm>
-            <a:off x="4612538" y="2926080"/>
-            <a:ext cx="2966618" cy="548640"/>
-          </a:xfrm>
-          <a:prstGeom prst="rect">
-            <a:avLst/>
-          </a:prstGeom>
-          <a:noFill/>
-          <a:ln/>
-        </p:spPr>
-        <p:txBody>
-          <a:bodyPr wrap="square" lIns="0" tIns="0" rIns="0" bIns="0" rtlCol="0" anchor="t"/>
-          <a:lstStyle/>
-          <a:p>
-            <a:pPr marL="0" indent="0">
-              <a:buNone/>
-            </a:pPr>
-            <a:r>
-              <a:rPr lang="en-US" sz="1400" dirty="0">
-                <a:solidFill>
-                  <a:srgbClr val="5E6A64"/>
-                </a:solidFill>
-                <a:latin typeface="Arial" pitchFamily="34" charset="0"/>
-                <a:ea typeface="Arial" pitchFamily="34" charset="-122"/>
-                <a:cs typeface="Arial" pitchFamily="34" charset="-120"/>
-              </a:rPr>
-              <a:t>Procurement costs and hedging</a:t>
-            </a:r>
-            <a:endParaRPr lang="en-US" sz="1400" dirty="0"/>
-          </a:p>
-        </p:txBody>
-      </p:sp>
-      <p:sp>
-        <p:nvSpPr>
-          <p:cNvPr id="14" name="Shape 10"/>
-          <p:cNvSpPr/>
-          <p:nvPr/>
-        </p:nvSpPr>
-        <p:spPr>
-          <a:xfrm>
-            <a:off x="8127797" y="1737360"/>
-            <a:ext cx="3515258" cy="1874520"/>
-          </a:xfrm>
-          <a:prstGeom prst="roundRect">
-            <a:avLst>
-              <a:gd name="adj" fmla="val 3902"/>
-            </a:avLst>
-          </a:prstGeom>
-          <a:solidFill>
-            <a:srgbClr val="F2F5F3"/>
-          </a:solidFill>
-          <a:ln w="9525">
-            <a:solidFill>
-              <a:srgbClr val="F2F5F3"/>
-            </a:solidFill>
-            <a:prstDash val="solid"/>
-          </a:ln>
-        </p:spPr>
-        <p:txBody>
-          <a:bodyPr/>
-          <a:lstStyle/>
-          <a:p>
-            <a:endParaRPr lang="en-US"/>
-          </a:p>
-        </p:txBody>
-      </p:sp>
-      <p:sp>
-        <p:nvSpPr>
-          <p:cNvPr id="15" name="Shape 11"/>
-          <p:cNvSpPr/>
-          <p:nvPr/>
-        </p:nvSpPr>
-        <p:spPr>
-          <a:xfrm>
-            <a:off x="8402117" y="2029968"/>
-            <a:ext cx="731520" cy="731520"/>
-          </a:xfrm>
-          <a:prstGeom prst="ellipse">
-            <a:avLst/>
-          </a:prstGeom>
-          <a:solidFill>
-            <a:srgbClr val="16302A"/>
-          </a:solidFill>
-          <a:ln w="9525">
-            <a:solidFill>
-              <a:srgbClr val="16302A"/>
-            </a:solidFill>
-            <a:prstDash val="solid"/>
-          </a:ln>
-        </p:spPr>
-        <p:txBody>
-          <a:bodyPr/>
-          <a:lstStyle/>
-          <a:p>
-            <a:endParaRPr lang="en-US"/>
-          </a:p>
-        </p:txBody>
-      </p:sp>
-      <p:pic>
-        <p:nvPicPr>
-          <p:cNvPr id="16" name="Image 2" descr="preencoded.png"/>
-          <p:cNvPicPr>
-            <a:picLocks noChangeAspect="1"/>
-          </p:cNvPicPr>
-          <p:nvPr/>
-        </p:nvPicPr>
-        <p:blipFill>
-          <a:blip r:embed="rId5"/>
-          <a:stretch>
-            <a:fillRect/>
-          </a:stretch>
-        </p:blipFill>
-        <p:spPr>
-          <a:xfrm>
-            <a:off x="8577682" y="2205533"/>
-            <a:ext cx="380390" cy="380390"/>
-          </a:xfrm>
-          <a:prstGeom prst="rect">
-            <a:avLst/>
-          </a:prstGeom>
-        </p:spPr>
-      </p:pic>
-      <p:sp>
-        <p:nvSpPr>
-          <p:cNvPr id="17" name="Text 12"/>
-          <p:cNvSpPr txBox="1"/>
-          <p:nvPr/>
-        </p:nvSpPr>
-        <p:spPr>
-          <a:xfrm>
-            <a:off x="9316517" y="2029968"/>
-            <a:ext cx="2097938" cy="731520"/>
-          </a:xfrm>
-          <a:prstGeom prst="rect">
-            <a:avLst/>
-          </a:prstGeom>
-          <a:noFill/>
-          <a:ln/>
-        </p:spPr>
-        <p:txBody>
-          <a:bodyPr wrap="square" lIns="0" tIns="0" rIns="0" bIns="0" rtlCol="0" anchor="ctr"/>
-          <a:lstStyle/>
-          <a:p>
-            <a:pPr marL="0" indent="0">
-              <a:buNone/>
-            </a:pPr>
-            <a:r>
-              <a:rPr lang="en-US" sz="1700" b="1" dirty="0">
-                <a:solidFill>
-                  <a:srgbClr val="1D2723"/>
-                </a:solidFill>
-                <a:latin typeface="Arial" pitchFamily="34" charset="0"/>
-                <a:ea typeface="Arial" pitchFamily="34" charset="-122"/>
-                <a:cs typeface="Arial" pitchFamily="34" charset="-120"/>
-              </a:rPr>
-              <a:t>Agribusiness and logistics</a:t>
-            </a:r>
-            <a:endParaRPr lang="en-US" sz="1700" dirty="0"/>
-          </a:p>
-        </p:txBody>
-      </p:sp>
-      <p:sp>
-        <p:nvSpPr>
-          <p:cNvPr id="18" name="Text 13"/>
-          <p:cNvSpPr txBox="1"/>
-          <p:nvPr/>
-        </p:nvSpPr>
-        <p:spPr>
-          <a:xfrm>
-            <a:off x="8402117" y="2926080"/>
-            <a:ext cx="2966618" cy="548640"/>
-          </a:xfrm>
-          <a:prstGeom prst="rect">
-            <a:avLst/>
-          </a:prstGeom>
-          <a:noFill/>
-          <a:ln/>
-        </p:spPr>
-        <p:txBody>
-          <a:bodyPr wrap="square" lIns="0" tIns="0" rIns="0" bIns="0" rtlCol="0" anchor="t"/>
-          <a:lstStyle/>
-          <a:p>
-            <a:pPr marL="0" indent="0">
-              <a:buNone/>
-            </a:pPr>
-            <a:r>
-              <a:rPr lang="en-US" sz="1400" dirty="0">
-                <a:solidFill>
-                  <a:srgbClr val="5E6A64"/>
-                </a:solidFill>
-                <a:latin typeface="Arial" pitchFamily="34" charset="0"/>
-                <a:ea typeface="Arial" pitchFamily="34" charset="-122"/>
-                <a:cs typeface="Arial" pitchFamily="34" charset="-120"/>
-              </a:rPr>
-              <a:t>Grain handlers, barge and rail operators, ports</a:t>
-            </a:r>
-            <a:endParaRPr lang="en-US" sz="1400" dirty="0"/>
-          </a:p>
-        </p:txBody>
-      </p:sp>
-      <p:sp>
-        <p:nvSpPr>
-          <p:cNvPr id="19" name="Shape 14"/>
-          <p:cNvSpPr/>
-          <p:nvPr/>
-        </p:nvSpPr>
-        <p:spPr>
-          <a:xfrm>
-            <a:off x="548640" y="3886200"/>
-            <a:ext cx="3515258" cy="1874520"/>
-          </a:xfrm>
-          <a:prstGeom prst="roundRect">
-            <a:avLst>
-              <a:gd name="adj" fmla="val 3902"/>
-            </a:avLst>
-          </a:prstGeom>
-          <a:solidFill>
-            <a:srgbClr val="F2F5F3"/>
-          </a:solidFill>
-          <a:ln w="9525">
-            <a:solidFill>
-              <a:srgbClr val="F2F5F3"/>
-            </a:solidFill>
-            <a:prstDash val="solid"/>
-          </a:ln>
-        </p:spPr>
-        <p:txBody>
-          <a:bodyPr/>
-          <a:lstStyle/>
-          <a:p>
-            <a:endParaRPr lang="en-US"/>
-          </a:p>
-        </p:txBody>
-      </p:sp>
-      <p:sp>
-        <p:nvSpPr>
-          <p:cNvPr id="20" name="Shape 15"/>
-          <p:cNvSpPr/>
-          <p:nvPr/>
-        </p:nvSpPr>
-        <p:spPr>
-          <a:xfrm>
-            <a:off x="822960" y="4178808"/>
-            <a:ext cx="731520" cy="731520"/>
-          </a:xfrm>
-          <a:prstGeom prst="ellipse">
-            <a:avLst/>
-          </a:prstGeom>
-          <a:solidFill>
-            <a:srgbClr val="16302A"/>
-          </a:solidFill>
-          <a:ln w="9525">
-            <a:solidFill>
-              <a:srgbClr val="16302A"/>
-            </a:solidFill>
-            <a:prstDash val="solid"/>
-          </a:ln>
-        </p:spPr>
-        <p:txBody>
-          <a:bodyPr/>
-          <a:lstStyle/>
-          <a:p>
-            <a:endParaRPr lang="en-US"/>
-          </a:p>
-        </p:txBody>
-      </p:sp>
-      <p:pic>
-        <p:nvPicPr>
-          <p:cNvPr id="21" name="Image 3" descr="preencoded.png"/>
-          <p:cNvPicPr>
-            <a:picLocks noChangeAspect="1"/>
-          </p:cNvPicPr>
-          <p:nvPr/>
-        </p:nvPicPr>
-        <p:blipFill>
-          <a:blip r:embed="rId6"/>
-          <a:stretch>
-            <a:fillRect/>
-          </a:stretch>
-        </p:blipFill>
-        <p:spPr>
-          <a:xfrm>
-            <a:off x="998525" y="4354373"/>
-            <a:ext cx="380390" cy="380390"/>
-          </a:xfrm>
-          <a:prstGeom prst="rect">
-            <a:avLst/>
-          </a:prstGeom>
-        </p:spPr>
-      </p:pic>
-      <p:sp>
-        <p:nvSpPr>
-          <p:cNvPr id="22" name="Text 16"/>
-          <p:cNvSpPr txBox="1"/>
-          <p:nvPr/>
-        </p:nvSpPr>
-        <p:spPr>
-          <a:xfrm>
-            <a:off x="1737360" y="4178808"/>
-            <a:ext cx="2097938" cy="731520"/>
-          </a:xfrm>
-          <a:prstGeom prst="rect">
-            <a:avLst/>
-          </a:prstGeom>
-          <a:noFill/>
-          <a:ln/>
-        </p:spPr>
-        <p:txBody>
-          <a:bodyPr wrap="square" lIns="0" tIns="0" rIns="0" bIns="0" rtlCol="0" anchor="ctr"/>
-          <a:lstStyle/>
-          <a:p>
-            <a:pPr marL="0" indent="0">
-              <a:buNone/>
-            </a:pPr>
-            <a:r>
-              <a:rPr lang="en-US" sz="1700" b="1" dirty="0">
-                <a:solidFill>
-                  <a:srgbClr val="1D2723"/>
-                </a:solidFill>
-                <a:latin typeface="Arial" pitchFamily="34" charset="0"/>
-                <a:ea typeface="Arial" pitchFamily="34" charset="-122"/>
-                <a:cs typeface="Arial" pitchFamily="34" charset="-120"/>
-              </a:rPr>
-              <a:t>Farmers and cooperatives</a:t>
-            </a:r>
-            <a:endParaRPr lang="en-US" sz="1700" dirty="0"/>
-          </a:p>
-        </p:txBody>
-      </p:sp>
-      <p:sp>
-        <p:nvSpPr>
-          <p:cNvPr id="23" name="Text 17"/>
-          <p:cNvSpPr txBox="1"/>
-          <p:nvPr/>
-        </p:nvSpPr>
-        <p:spPr>
-          <a:xfrm>
-            <a:off x="822960" y="5074920"/>
-            <a:ext cx="2966618" cy="548640"/>
-          </a:xfrm>
-          <a:prstGeom prst="rect">
-            <a:avLst/>
-          </a:prstGeom>
-          <a:noFill/>
-          <a:ln/>
-        </p:spPr>
-        <p:txBody>
-          <a:bodyPr wrap="square" lIns="0" tIns="0" rIns="0" bIns="0" rtlCol="0" anchor="t"/>
-          <a:lstStyle/>
-          <a:p>
-            <a:pPr marL="0" indent="0">
-              <a:buNone/>
-            </a:pPr>
-            <a:r>
-              <a:rPr lang="en-US" sz="1400" dirty="0">
-                <a:solidFill>
-                  <a:srgbClr val="5E6A64"/>
-                </a:solidFill>
-                <a:latin typeface="Arial" pitchFamily="34" charset="0"/>
-                <a:ea typeface="Arial" pitchFamily="34" charset="-122"/>
-                <a:cs typeface="Arial" pitchFamily="34" charset="-120"/>
-              </a:rPr>
-              <a:t>Hedging and marketing decisions</a:t>
-            </a:r>
-            <a:endParaRPr lang="en-US" sz="1400" dirty="0"/>
-          </a:p>
-        </p:txBody>
-      </p:sp>
-      <p:sp>
-        <p:nvSpPr>
-          <p:cNvPr id="24" name="Shape 18"/>
-          <p:cNvSpPr/>
-          <p:nvPr/>
-        </p:nvSpPr>
-        <p:spPr>
-          <a:xfrm>
-            <a:off x="4338218" y="3886200"/>
-            <a:ext cx="3515258" cy="1874520"/>
-          </a:xfrm>
-          <a:prstGeom prst="roundRect">
-            <a:avLst>
-              <a:gd name="adj" fmla="val 3902"/>
-            </a:avLst>
-          </a:prstGeom>
-          <a:solidFill>
-            <a:srgbClr val="F2F5F3"/>
-          </a:solidFill>
-          <a:ln w="9525">
-            <a:solidFill>
-              <a:srgbClr val="F2F5F3"/>
-            </a:solidFill>
-            <a:prstDash val="solid"/>
-          </a:ln>
-        </p:spPr>
-        <p:txBody>
-          <a:bodyPr/>
-          <a:lstStyle/>
-          <a:p>
-            <a:endParaRPr lang="en-US"/>
-          </a:p>
-        </p:txBody>
-      </p:sp>
-      <p:sp>
-        <p:nvSpPr>
-          <p:cNvPr id="25" name="Shape 19"/>
-          <p:cNvSpPr/>
-          <p:nvPr/>
-        </p:nvSpPr>
-        <p:spPr>
-          <a:xfrm>
-            <a:off x="4612538" y="4178808"/>
-            <a:ext cx="731520" cy="731520"/>
-          </a:xfrm>
-          <a:prstGeom prst="ellipse">
-            <a:avLst/>
-          </a:prstGeom>
-          <a:solidFill>
-            <a:srgbClr val="16302A"/>
-          </a:solidFill>
-          <a:ln w="9525">
-            <a:solidFill>
-              <a:srgbClr val="16302A"/>
-            </a:solidFill>
-            <a:prstDash val="solid"/>
-          </a:ln>
-        </p:spPr>
-        <p:txBody>
-          <a:bodyPr/>
-          <a:lstStyle/>
-          <a:p>
-            <a:endParaRPr lang="en-US"/>
-          </a:p>
-        </p:txBody>
-      </p:sp>
-      <p:pic>
-        <p:nvPicPr>
-          <p:cNvPr id="26" name="Image 4" descr="preencoded.png"/>
-          <p:cNvPicPr>
-            <a:picLocks noChangeAspect="1"/>
-          </p:cNvPicPr>
-          <p:nvPr/>
-        </p:nvPicPr>
-        <p:blipFill>
-          <a:blip r:embed="rId7"/>
-          <a:stretch>
-            <a:fillRect/>
-          </a:stretch>
-        </p:blipFill>
-        <p:spPr>
-          <a:xfrm>
-            <a:off x="4788103" y="4354373"/>
-            <a:ext cx="380390" cy="380390"/>
-          </a:xfrm>
-          <a:prstGeom prst="rect">
-            <a:avLst/>
-          </a:prstGeom>
-        </p:spPr>
-      </p:pic>
-      <p:sp>
-        <p:nvSpPr>
-          <p:cNvPr id="27" name="Text 20"/>
-          <p:cNvSpPr txBox="1"/>
-          <p:nvPr/>
-        </p:nvSpPr>
-        <p:spPr>
-          <a:xfrm>
-            <a:off x="5526938" y="4178808"/>
-            <a:ext cx="2097938" cy="731520"/>
-          </a:xfrm>
-          <a:prstGeom prst="rect">
-            <a:avLst/>
-          </a:prstGeom>
-          <a:noFill/>
-          <a:ln/>
-        </p:spPr>
-        <p:txBody>
-          <a:bodyPr wrap="square" lIns="0" tIns="0" rIns="0" bIns="0" rtlCol="0" anchor="ctr"/>
-          <a:lstStyle/>
-          <a:p>
-            <a:pPr marL="0" indent="0">
-              <a:buNone/>
-            </a:pPr>
-            <a:r>
-              <a:rPr lang="en-US" sz="1700" b="1" dirty="0">
-                <a:solidFill>
-                  <a:srgbClr val="1D2723"/>
-                </a:solidFill>
-                <a:latin typeface="Arial" pitchFamily="34" charset="0"/>
-                <a:ea typeface="Arial" pitchFamily="34" charset="-122"/>
-                <a:cs typeface="Arial" pitchFamily="34" charset="-120"/>
-              </a:rPr>
-              <a:t>Insurers and lenders</a:t>
-            </a:r>
-            <a:endParaRPr lang="en-US" sz="1700" dirty="0"/>
-          </a:p>
-        </p:txBody>
-      </p:sp>
-      <p:sp>
-        <p:nvSpPr>
-          <p:cNvPr id="28" name="Text 21"/>
-          <p:cNvSpPr txBox="1"/>
-          <p:nvPr/>
-        </p:nvSpPr>
-        <p:spPr>
-          <a:xfrm>
-            <a:off x="4612538" y="5074920"/>
-            <a:ext cx="2966618" cy="548640"/>
-          </a:xfrm>
-          <a:prstGeom prst="rect">
-            <a:avLst/>
-          </a:prstGeom>
-          <a:noFill/>
-          <a:ln/>
-        </p:spPr>
-        <p:txBody>
-          <a:bodyPr wrap="square" lIns="0" tIns="0" rIns="0" bIns="0" rtlCol="0" anchor="t"/>
-          <a:lstStyle/>
-          <a:p>
-            <a:pPr marL="0" indent="0">
-              <a:buNone/>
-            </a:pPr>
-            <a:r>
-              <a:rPr lang="en-US" sz="1400" dirty="0">
-                <a:solidFill>
-                  <a:srgbClr val="5E6A64"/>
-                </a:solidFill>
-                <a:latin typeface="Arial" pitchFamily="34" charset="0"/>
-                <a:ea typeface="Arial" pitchFamily="34" charset="-122"/>
-                <a:cs typeface="Arial" pitchFamily="34" charset="-120"/>
-              </a:rPr>
-              <a:t>Crop insurance and agricultural credit risk</a:t>
-            </a:r>
-            <a:endParaRPr lang="en-US" sz="1400" dirty="0"/>
-          </a:p>
-        </p:txBody>
-      </p:sp>
-      <p:sp>
-        <p:nvSpPr>
-          <p:cNvPr id="29" name="Shape 22"/>
-          <p:cNvSpPr/>
-          <p:nvPr/>
-        </p:nvSpPr>
-        <p:spPr>
-          <a:xfrm>
-            <a:off x="8127797" y="3886200"/>
-            <a:ext cx="3515258" cy="1874520"/>
-          </a:xfrm>
-          <a:prstGeom prst="roundRect">
-            <a:avLst>
-              <a:gd name="adj" fmla="val 3902"/>
-            </a:avLst>
-          </a:prstGeom>
-          <a:solidFill>
-            <a:srgbClr val="F2F5F3"/>
-          </a:solidFill>
-          <a:ln w="9525">
-            <a:solidFill>
-              <a:srgbClr val="F2F5F3"/>
-            </a:solidFill>
-            <a:prstDash val="solid"/>
-          </a:ln>
-        </p:spPr>
-        <p:txBody>
-          <a:bodyPr/>
-          <a:lstStyle/>
-          <a:p>
-            <a:endParaRPr lang="en-US"/>
-          </a:p>
-        </p:txBody>
-      </p:sp>
-      <p:sp>
-        <p:nvSpPr>
-          <p:cNvPr id="30" name="Shape 23"/>
-          <p:cNvSpPr/>
-          <p:nvPr/>
-        </p:nvSpPr>
-        <p:spPr>
-          <a:xfrm>
-            <a:off x="8402117" y="4178808"/>
-            <a:ext cx="731520" cy="731520"/>
-          </a:xfrm>
-          <a:prstGeom prst="ellipse">
-            <a:avLst/>
-          </a:prstGeom>
-          <a:solidFill>
-            <a:srgbClr val="16302A"/>
-          </a:solidFill>
-          <a:ln w="9525">
-            <a:solidFill>
-              <a:srgbClr val="16302A"/>
-            </a:solidFill>
-            <a:prstDash val="solid"/>
-          </a:ln>
-        </p:spPr>
-        <p:txBody>
-          <a:bodyPr/>
-          <a:lstStyle/>
-          <a:p>
-            <a:endParaRPr lang="en-US"/>
-          </a:p>
-        </p:txBody>
-      </p:sp>
-      <p:pic>
-        <p:nvPicPr>
-          <p:cNvPr id="31" name="Image 5" descr="preencoded.png"/>
-          <p:cNvPicPr>
-            <a:picLocks noChangeAspect="1"/>
-          </p:cNvPicPr>
-          <p:nvPr/>
-        </p:nvPicPr>
-        <p:blipFill>
-          <a:blip r:embed="rId8"/>
-          <a:stretch>
-            <a:fillRect/>
-          </a:stretch>
-        </p:blipFill>
-        <p:spPr>
-          <a:xfrm>
-            <a:off x="8577682" y="4354373"/>
-            <a:ext cx="380390" cy="380390"/>
-          </a:xfrm>
-          <a:prstGeom prst="rect">
-            <a:avLst/>
-          </a:prstGeom>
-        </p:spPr>
-      </p:pic>
-      <p:sp>
-        <p:nvSpPr>
-          <p:cNvPr id="32" name="Text 24"/>
-          <p:cNvSpPr txBox="1"/>
-          <p:nvPr/>
-        </p:nvSpPr>
-        <p:spPr>
-          <a:xfrm>
-            <a:off x="9316517" y="4178808"/>
-            <a:ext cx="2097938" cy="731520"/>
-          </a:xfrm>
-          <a:prstGeom prst="rect">
-            <a:avLst/>
-          </a:prstGeom>
-          <a:noFill/>
-          <a:ln/>
-        </p:spPr>
-        <p:txBody>
-          <a:bodyPr wrap="square" lIns="0" tIns="0" rIns="0" bIns="0" rtlCol="0" anchor="ctr"/>
-          <a:lstStyle/>
-          <a:p>
-            <a:pPr marL="0" indent="0">
-              <a:buNone/>
-            </a:pPr>
-            <a:r>
-              <a:rPr lang="en-US" sz="1700" b="1" dirty="0">
-                <a:solidFill>
-                  <a:srgbClr val="1D2723"/>
-                </a:solidFill>
-                <a:latin typeface="Arial" pitchFamily="34" charset="0"/>
-                <a:ea typeface="Arial" pitchFamily="34" charset="-122"/>
-                <a:cs typeface="Arial" pitchFamily="34" charset="-120"/>
-              </a:rPr>
-              <a:t>Policymakers and consumers</a:t>
-            </a:r>
-            <a:endParaRPr lang="en-US" sz="1700" dirty="0"/>
-          </a:p>
-        </p:txBody>
-      </p:sp>
-      <p:sp>
-        <p:nvSpPr>
-          <p:cNvPr id="33" name="Text 25"/>
-          <p:cNvSpPr txBox="1"/>
-          <p:nvPr/>
-        </p:nvSpPr>
-        <p:spPr>
-          <a:xfrm>
-            <a:off x="8402117" y="5074920"/>
-            <a:ext cx="2966618" cy="548640"/>
-          </a:xfrm>
-          <a:prstGeom prst="rect">
-            <a:avLst/>
-          </a:prstGeom>
-          <a:noFill/>
-          <a:ln/>
-        </p:spPr>
-        <p:txBody>
-          <a:bodyPr wrap="square" lIns="0" tIns="0" rIns="0" bIns="0" rtlCol="0" anchor="t"/>
-          <a:lstStyle/>
-          <a:p>
-            <a:pPr marL="0" indent="0">
-              <a:buNone/>
-            </a:pPr>
-            <a:r>
-              <a:rPr lang="en-US" sz="1400" dirty="0">
-                <a:solidFill>
-                  <a:srgbClr val="5E6A64"/>
-                </a:solidFill>
-                <a:latin typeface="Arial" pitchFamily="34" charset="0"/>
-                <a:ea typeface="Arial" pitchFamily="34" charset="-122"/>
-                <a:cs typeface="Arial" pitchFamily="34" charset="-120"/>
-              </a:rPr>
-              <a:t>Food security and food prices</a:t>
-            </a:r>
-            <a:endParaRPr lang="en-US" sz="1400" dirty="0"/>
-          </a:p>
-        </p:txBody>
-      </p:sp>
-      <p:sp>
-        <p:nvSpPr>
-          <p:cNvPr id="34" name="Text 26"/>
-          <p:cNvSpPr txBox="1"/>
-          <p:nvPr/>
-        </p:nvSpPr>
-        <p:spPr>
-          <a:xfrm>
-            <a:off x="548640" y="5870448"/>
-            <a:ext cx="10424160" cy="365760"/>
-          </a:xfrm>
-          <a:prstGeom prst="rect">
-            <a:avLst/>
-          </a:prstGeom>
-          <a:noFill/>
-          <a:ln/>
-        </p:spPr>
-        <p:txBody>
-          <a:bodyPr wrap="square" lIns="0" tIns="0" rIns="0" bIns="0" rtlCol="0" anchor="ctr"/>
-          <a:lstStyle/>
-          <a:p>
-            <a:pPr marL="0" indent="0">
-              <a:buNone/>
-            </a:pPr>
-            <a:r>
-              <a:rPr lang="en-US" sz="1500" i="1" dirty="0">
-                <a:solidFill>
-                  <a:srgbClr val="2E6B4F"/>
-                </a:solidFill>
-                <a:latin typeface="Arial" pitchFamily="34" charset="0"/>
-                <a:ea typeface="Arial" pitchFamily="34" charset="-122"/>
-                <a:cs typeface="Arial" pitchFamily="34" charset="-120"/>
-              </a:rPr>
-              <a:t>Even if traders already price the weather, a validated risk score helps everyone who does not trade.</a:t>
-            </a:r>
-            <a:endParaRPr lang="en-US" sz="1500" dirty="0"/>
-          </a:p>
-        </p:txBody>
-      </p:sp>
-      <p:sp>
-        <p:nvSpPr>
-          <p:cNvPr id="35" name="Slide Number Placeholder 0"/>
-          <p:cNvSpPr>
-            <a:spLocks noGrp="1"/>
-          </p:cNvSpPr>
-          <p:nvPr>
-            <p:ph type="sldNum" sz="quarter" idx="4294967295"/>
-          </p:nvPr>
-        </p:nvSpPr>
-        <p:spPr>
-          <a:xfrm>
-            <a:off x="11183112" y="6309360"/>
-            <a:ext cx="457200" cy="274320"/>
-          </a:xfrm>
-          <a:prstGeom prst="rect">
-            <a:avLst/>
-          </a:prstGeom>
-          <a:extLst>
-            <a:ext uri="{C572A759-6A51-4108-AA02-DFA0A04FC94B}">
-              <ma14:wrappingTextBoxFlag xmlns:ma14="http://schemas.microsoft.com/office/mac/drawingml/2011/main" xmlns="" val="0"/>
-            </a:ext>
-          </a:extLst>
-        </p:spPr>
-        <p:txBody>
-          <a:bodyPr/>
-          <a:lstStyle>
-            <a:lvl1pPr>
-              <a:defRPr sz="1000">
-                <a:solidFill>
-                  <a:srgbClr val="5E6A64"/>
-                </a:solidFill>
-                <a:latin typeface="Arial"/>
-                <a:ea typeface="Arial"/>
-                <a:cs typeface="Arial"/>
-              </a:defRPr>
-            </a:lvl1pPr>
-          </a:lstStyle>
-          <a:p>
-            <a:pPr algn="r"/>
-            <a:fld id="{F7021451-1387-4CA6-816F-3879F97B5CBC}" type="slidenum">
-              <a:rPr lang="en-US" b="0"/>
-              <a:t>4</a:t>
-            </a:fld>
-            <a:endParaRPr lang="en-US"/>
-          </a:p>
-        </p:txBody>
-      </p:sp>
-    </p:spTree>
-  </p:cSld>
-  <p:clrMapOvr>
-    <a:masterClrMapping/>
-  </p:clrMapOvr>
-</p:sld>
-</file>
-
-<file path=ppt/slides/slide5.xml><?xml version="1.0" encoding="utf-8"?>
 <p:sld xmlns:a="http://schemas.openxmlformats.org/drawingml/2006/main" xmlns:r="http://schemas.openxmlformats.org/officeDocument/2006/relationships" xmlns:p="http://schemas.openxmlformats.org/presentationml/2006/main">
   <p:cSld name="Slide 5">
     <p:spTree>
@@ -14350,7 +13152,7 @@
             <a:pPr algn="r"/>
             <a:fld id="{F7021451-1387-4CA6-816F-3879F97B5CBC}" type="slidenum">
               <a:rPr lang="en-US" b="0"/>
-              <a:t>5</a:t>
+              <a:t>4</a:t>
             </a:fld>
             <a:endParaRPr lang="en-US"/>
           </a:p>
@@ -14364,7 +13166,7 @@
 </p:sld>
 </file>
 
-<file path=ppt/slides/slide6.xml><?xml version="1.0" encoding="utf-8"?>
+<file path=ppt/slides/slide5.xml><?xml version="1.0" encoding="utf-8"?>
 <p:sld xmlns:a="http://schemas.openxmlformats.org/drawingml/2006/main" xmlns:r="http://schemas.openxmlformats.org/officeDocument/2006/relationships" xmlns:p="http://schemas.openxmlformats.org/presentationml/2006/main">
   <p:cSld name="Slide 6">
     <p:spTree>
@@ -14911,7 +13713,7 @@
             <a:pPr algn="r"/>
             <a:fld id="{F7021451-1387-4CA6-816F-3879F97B5CBC}" type="slidenum">
               <a:rPr lang="en-US" b="0"/>
-              <a:t>6</a:t>
+              <a:t>5</a:t>
             </a:fld>
             <a:endParaRPr lang="en-US"/>
           </a:p>
@@ -14925,7 +13727,7 @@
 </p:sld>
 </file>
 
-<file path=ppt/slides/slide7.xml><?xml version="1.0" encoding="utf-8"?>
+<file path=ppt/slides/slide6.xml><?xml version="1.0" encoding="utf-8"?>
 <p:sld xmlns:a="http://schemas.openxmlformats.org/drawingml/2006/main" xmlns:r="http://schemas.openxmlformats.org/officeDocument/2006/relationships" xmlns:p="http://schemas.openxmlformats.org/presentationml/2006/main">
   <p:cSld name="Slide 7">
     <p:spTree>
@@ -15351,7 +14153,7 @@
             <a:pPr algn="r"/>
             <a:fld id="{F7021451-1387-4CA6-816F-3879F97B5CBC}" type="slidenum">
               <a:rPr lang="en-US" b="0"/>
-              <a:t>7</a:t>
+              <a:t>6</a:t>
             </a:fld>
             <a:endParaRPr lang="en-US"/>
           </a:p>
@@ -15365,7 +14167,7 @@
 </p:sld>
 </file>
 
-<file path=ppt/slides/slide8.xml><?xml version="1.0" encoding="utf-8"?>
+<file path=ppt/slides/slide7.xml><?xml version="1.0" encoding="utf-8"?>
 <p:sld xmlns:a="http://schemas.openxmlformats.org/drawingml/2006/main" xmlns:r="http://schemas.openxmlformats.org/officeDocument/2006/relationships" xmlns:p="http://schemas.openxmlformats.org/presentationml/2006/main">
   <p:cSld name="Slide 8">
     <p:spTree>
@@ -15825,7 +14627,7 @@
             <a:pPr algn="r"/>
             <a:fld id="{F7021451-1387-4CA6-816F-3879F97B5CBC}" type="slidenum">
               <a:rPr lang="en-US" b="0"/>
-              <a:t>8</a:t>
+              <a:t>7</a:t>
             </a:fld>
             <a:endParaRPr lang="en-US"/>
           </a:p>
@@ -15839,7 +14641,7 @@
 </p:sld>
 </file>
 
-<file path=ppt/slides/slide9.xml><?xml version="1.0" encoding="utf-8"?>
+<file path=ppt/slides/slide8.xml><?xml version="1.0" encoding="utf-8"?>
 <p:sld xmlns:a="http://schemas.openxmlformats.org/drawingml/2006/main" xmlns:r="http://schemas.openxmlformats.org/officeDocument/2006/relationships" xmlns:p="http://schemas.openxmlformats.org/presentationml/2006/main">
   <p:cSld name="Slide 9">
     <p:spTree>
@@ -16726,6 +15528,1204 @@
       <p:sp>
         <p:nvSpPr>
           <p:cNvPr id="27" name="Slide Number Placeholder 0"/>
+          <p:cNvSpPr>
+            <a:spLocks noGrp="1"/>
+          </p:cNvSpPr>
+          <p:nvPr>
+            <p:ph type="sldNum" sz="quarter" idx="4294967295"/>
+          </p:nvPr>
+        </p:nvSpPr>
+        <p:spPr>
+          <a:xfrm>
+            <a:off x="11183112" y="6309360"/>
+            <a:ext cx="457200" cy="274320"/>
+          </a:xfrm>
+          <a:prstGeom prst="rect">
+            <a:avLst/>
+          </a:prstGeom>
+          <a:extLst>
+            <a:ext uri="{C572A759-6A51-4108-AA02-DFA0A04FC94B}">
+              <ma14:wrappingTextBoxFlag xmlns:ma14="http://schemas.microsoft.com/office/mac/drawingml/2011/main" xmlns="" val="0"/>
+            </a:ext>
+          </a:extLst>
+        </p:spPr>
+        <p:txBody>
+          <a:bodyPr/>
+          <a:lstStyle>
+            <a:lvl1pPr>
+              <a:defRPr sz="1000">
+                <a:solidFill>
+                  <a:srgbClr val="5E6A64"/>
+                </a:solidFill>
+                <a:latin typeface="Arial"/>
+                <a:ea typeface="Arial"/>
+                <a:cs typeface="Arial"/>
+              </a:defRPr>
+            </a:lvl1pPr>
+          </a:lstStyle>
+          <a:p>
+            <a:pPr algn="r"/>
+            <a:fld id="{F7021451-1387-4CA6-816F-3879F97B5CBC}" type="slidenum">
+              <a:rPr lang="en-US" b="0"/>
+              <a:t>8</a:t>
+            </a:fld>
+            <a:endParaRPr lang="en-US"/>
+          </a:p>
+        </p:txBody>
+      </p:sp>
+    </p:spTree>
+  </p:cSld>
+  <p:clrMapOvr>
+    <a:masterClrMapping/>
+  </p:clrMapOvr>
+</p:sld>
+</file>
+
+<file path=ppt/slides/slide9.xml><?xml version="1.0" encoding="utf-8"?>
+<p:sld xmlns:a="http://schemas.openxmlformats.org/drawingml/2006/main" xmlns:r="http://schemas.openxmlformats.org/officeDocument/2006/relationships" xmlns:p="http://schemas.openxmlformats.org/presentationml/2006/main">
+  <p:cSld name="Slide 4">
+    <p:spTree>
+      <p:nvGrpSpPr>
+        <p:cNvPr id="1" name=""/>
+        <p:cNvGrpSpPr/>
+        <p:nvPr/>
+      </p:nvGrpSpPr>
+      <p:grpSpPr>
+        <a:xfrm>
+          <a:off x="0" y="0"/>
+          <a:ext cx="0" cy="0"/>
+          <a:chOff x="0" y="0"/>
+          <a:chExt cx="0" cy="0"/>
+        </a:xfrm>
+      </p:grpSpPr>
+      <p:sp>
+        <p:nvSpPr>
+          <p:cNvPr id="2" name="Text 0"/>
+          <p:cNvSpPr txBox="1"/>
+          <p:nvPr/>
+        </p:nvSpPr>
+        <p:spPr>
+          <a:xfrm>
+            <a:off x="548640" y="384048"/>
+            <a:ext cx="11094415" cy="658368"/>
+          </a:xfrm>
+          <a:prstGeom prst="rect">
+            <a:avLst/>
+          </a:prstGeom>
+          <a:noFill/>
+          <a:ln/>
+        </p:spPr>
+        <p:txBody>
+          <a:bodyPr wrap="square" lIns="0" tIns="0" rIns="0" bIns="0" rtlCol="0" anchor="ctr"/>
+          <a:lstStyle/>
+          <a:p>
+            <a:pPr marL="0" indent="0">
+              <a:buNone/>
+            </a:pPr>
+            <a:r>
+              <a:rPr lang="en-US" sz="3600" b="1" dirty="0">
+                <a:solidFill>
+                  <a:srgbClr val="1D2723"/>
+                </a:solidFill>
+                <a:latin typeface="Georgia" pitchFamily="34" charset="0"/>
+                <a:ea typeface="Georgia" pitchFamily="34" charset="-122"/>
+                <a:cs typeface="Georgia" pitchFamily="34" charset="-120"/>
+              </a:rPr>
+              <a:t>Stakeholders</a:t>
+            </a:r>
+            <a:endParaRPr lang="en-US" sz="3600" dirty="0"/>
+          </a:p>
+        </p:txBody>
+      </p:sp>
+      <p:sp>
+        <p:nvSpPr>
+          <p:cNvPr id="3" name="Text 1"/>
+          <p:cNvSpPr txBox="1"/>
+          <p:nvPr/>
+        </p:nvSpPr>
+        <p:spPr>
+          <a:xfrm>
+            <a:off x="548640" y="1042416"/>
+            <a:ext cx="11094415" cy="402336"/>
+          </a:xfrm>
+          <a:prstGeom prst="rect">
+            <a:avLst/>
+          </a:prstGeom>
+          <a:noFill/>
+          <a:ln/>
+        </p:spPr>
+        <p:txBody>
+          <a:bodyPr wrap="square" lIns="0" tIns="0" rIns="0" bIns="0" rtlCol="0" anchor="ctr"/>
+          <a:lstStyle/>
+          <a:p>
+            <a:pPr marL="0" indent="0">
+              <a:buNone/>
+            </a:pPr>
+            <a:r>
+              <a:rPr lang="en-US" sz="1800" dirty="0">
+                <a:solidFill>
+                  <a:srgbClr val="5E6A64"/>
+                </a:solidFill>
+                <a:latin typeface="Arial" pitchFamily="34" charset="0"/>
+                <a:ea typeface="Arial" pitchFamily="34" charset="-122"/>
+                <a:cs typeface="Arial" pitchFamily="34" charset="-120"/>
+              </a:rPr>
+              <a:t>Who needs to know when weather becomes a supply shock</a:t>
+            </a:r>
+            <a:endParaRPr lang="en-US" sz="1800" dirty="0"/>
+          </a:p>
+        </p:txBody>
+      </p:sp>
+      <p:sp>
+        <p:nvSpPr>
+          <p:cNvPr id="4" name="Shape 2"/>
+          <p:cNvSpPr/>
+          <p:nvPr/>
+        </p:nvSpPr>
+        <p:spPr>
+          <a:xfrm>
+            <a:off x="548640" y="1737360"/>
+            <a:ext cx="3515258" cy="1874520"/>
+          </a:xfrm>
+          <a:prstGeom prst="roundRect">
+            <a:avLst>
+              <a:gd name="adj" fmla="val 3902"/>
+            </a:avLst>
+          </a:prstGeom>
+          <a:solidFill>
+            <a:srgbClr val="F2F5F3"/>
+          </a:solidFill>
+          <a:ln w="9525">
+            <a:solidFill>
+              <a:srgbClr val="F2F5F3"/>
+            </a:solidFill>
+            <a:prstDash val="solid"/>
+          </a:ln>
+        </p:spPr>
+        <p:txBody>
+          <a:bodyPr/>
+          <a:lstStyle/>
+          <a:p>
+            <a:endParaRPr lang="en-US"/>
+          </a:p>
+        </p:txBody>
+      </p:sp>
+      <p:sp>
+        <p:nvSpPr>
+          <p:cNvPr id="5" name="Shape 3"/>
+          <p:cNvSpPr/>
+          <p:nvPr/>
+        </p:nvSpPr>
+        <p:spPr>
+          <a:xfrm>
+            <a:off x="822960" y="2029968"/>
+            <a:ext cx="731520" cy="731520"/>
+          </a:xfrm>
+          <a:prstGeom prst="ellipse">
+            <a:avLst/>
+          </a:prstGeom>
+          <a:solidFill>
+            <a:srgbClr val="16302A"/>
+          </a:solidFill>
+          <a:ln w="9525">
+            <a:solidFill>
+              <a:srgbClr val="16302A"/>
+            </a:solidFill>
+            <a:prstDash val="solid"/>
+          </a:ln>
+        </p:spPr>
+        <p:txBody>
+          <a:bodyPr/>
+          <a:lstStyle/>
+          <a:p>
+            <a:endParaRPr lang="en-US"/>
+          </a:p>
+        </p:txBody>
+      </p:sp>
+      <p:pic>
+        <p:nvPicPr>
+          <p:cNvPr id="6" name="Image 0" descr="preencoded.png"/>
+          <p:cNvPicPr>
+            <a:picLocks noChangeAspect="1"/>
+          </p:cNvPicPr>
+          <p:nvPr/>
+        </p:nvPicPr>
+        <p:blipFill>
+          <a:blip r:embed="rId3"/>
+          <a:stretch>
+            <a:fillRect/>
+          </a:stretch>
+        </p:blipFill>
+        <p:spPr>
+          <a:xfrm>
+            <a:off x="998525" y="2205533"/>
+            <a:ext cx="380390" cy="380390"/>
+          </a:xfrm>
+          <a:prstGeom prst="rect">
+            <a:avLst/>
+          </a:prstGeom>
+        </p:spPr>
+      </p:pic>
+      <p:sp>
+        <p:nvSpPr>
+          <p:cNvPr id="7" name="Text 4"/>
+          <p:cNvSpPr txBox="1"/>
+          <p:nvPr/>
+        </p:nvSpPr>
+        <p:spPr>
+          <a:xfrm>
+            <a:off x="1737360" y="2029968"/>
+            <a:ext cx="2097938" cy="731520"/>
+          </a:xfrm>
+          <a:prstGeom prst="rect">
+            <a:avLst/>
+          </a:prstGeom>
+          <a:noFill/>
+          <a:ln/>
+        </p:spPr>
+        <p:txBody>
+          <a:bodyPr wrap="square" lIns="0" tIns="0" rIns="0" bIns="0" rtlCol="0" anchor="ctr"/>
+          <a:lstStyle/>
+          <a:p>
+            <a:pPr marL="0" indent="0">
+              <a:buNone/>
+            </a:pPr>
+            <a:r>
+              <a:rPr lang="en-US" sz="1700" b="1" dirty="0">
+                <a:solidFill>
+                  <a:srgbClr val="1D2723"/>
+                </a:solidFill>
+                <a:latin typeface="Arial" pitchFamily="34" charset="0"/>
+                <a:ea typeface="Arial" pitchFamily="34" charset="-122"/>
+                <a:cs typeface="Arial" pitchFamily="34" charset="-120"/>
+              </a:rPr>
+              <a:t>Commodity traders and funds</a:t>
+            </a:r>
+            <a:endParaRPr lang="en-US" sz="1700" dirty="0"/>
+          </a:p>
+        </p:txBody>
+      </p:sp>
+      <p:sp>
+        <p:nvSpPr>
+          <p:cNvPr id="8" name="Text 5"/>
+          <p:cNvSpPr txBox="1"/>
+          <p:nvPr/>
+        </p:nvSpPr>
+        <p:spPr>
+          <a:xfrm>
+            <a:off x="822960" y="2926080"/>
+            <a:ext cx="2966618" cy="548640"/>
+          </a:xfrm>
+          <a:prstGeom prst="rect">
+            <a:avLst/>
+          </a:prstGeom>
+          <a:noFill/>
+          <a:ln/>
+        </p:spPr>
+        <p:txBody>
+          <a:bodyPr wrap="square" lIns="0" tIns="0" rIns="0" bIns="0" rtlCol="0" anchor="t"/>
+          <a:lstStyle/>
+          <a:p>
+            <a:pPr marL="0" indent="0">
+              <a:buNone/>
+            </a:pPr>
+            <a:r>
+              <a:rPr lang="en-US" sz="1400" dirty="0">
+                <a:solidFill>
+                  <a:srgbClr val="5E6A64"/>
+                </a:solidFill>
+                <a:latin typeface="Arial" pitchFamily="34" charset="0"/>
+                <a:ea typeface="Arial" pitchFamily="34" charset="-122"/>
+                <a:cs typeface="Arial" pitchFamily="34" charset="-120"/>
+              </a:rPr>
+              <a:t>Price risk and trading signals</a:t>
+            </a:r>
+            <a:endParaRPr lang="en-US" sz="1400" dirty="0"/>
+          </a:p>
+        </p:txBody>
+      </p:sp>
+      <p:sp>
+        <p:nvSpPr>
+          <p:cNvPr id="9" name="Shape 6"/>
+          <p:cNvSpPr/>
+          <p:nvPr/>
+        </p:nvSpPr>
+        <p:spPr>
+          <a:xfrm>
+            <a:off x="4338218" y="1737360"/>
+            <a:ext cx="3515258" cy="1874520"/>
+          </a:xfrm>
+          <a:prstGeom prst="roundRect">
+            <a:avLst>
+              <a:gd name="adj" fmla="val 3902"/>
+            </a:avLst>
+          </a:prstGeom>
+          <a:solidFill>
+            <a:srgbClr val="F2F5F3"/>
+          </a:solidFill>
+          <a:ln w="9525">
+            <a:solidFill>
+              <a:srgbClr val="F2F5F3"/>
+            </a:solidFill>
+            <a:prstDash val="solid"/>
+          </a:ln>
+        </p:spPr>
+        <p:txBody>
+          <a:bodyPr/>
+          <a:lstStyle/>
+          <a:p>
+            <a:endParaRPr lang="en-US"/>
+          </a:p>
+        </p:txBody>
+      </p:sp>
+      <p:sp>
+        <p:nvSpPr>
+          <p:cNvPr id="10" name="Shape 7"/>
+          <p:cNvSpPr/>
+          <p:nvPr/>
+        </p:nvSpPr>
+        <p:spPr>
+          <a:xfrm>
+            <a:off x="4612538" y="2029968"/>
+            <a:ext cx="731520" cy="731520"/>
+          </a:xfrm>
+          <a:prstGeom prst="ellipse">
+            <a:avLst/>
+          </a:prstGeom>
+          <a:solidFill>
+            <a:srgbClr val="16302A"/>
+          </a:solidFill>
+          <a:ln w="9525">
+            <a:solidFill>
+              <a:srgbClr val="16302A"/>
+            </a:solidFill>
+            <a:prstDash val="solid"/>
+          </a:ln>
+        </p:spPr>
+        <p:txBody>
+          <a:bodyPr/>
+          <a:lstStyle/>
+          <a:p>
+            <a:endParaRPr lang="en-US"/>
+          </a:p>
+        </p:txBody>
+      </p:sp>
+      <p:pic>
+        <p:nvPicPr>
+          <p:cNvPr id="11" name="Image 1" descr="preencoded.png"/>
+          <p:cNvPicPr>
+            <a:picLocks noChangeAspect="1"/>
+          </p:cNvPicPr>
+          <p:nvPr/>
+        </p:nvPicPr>
+        <p:blipFill>
+          <a:blip r:embed="rId4"/>
+          <a:stretch>
+            <a:fillRect/>
+          </a:stretch>
+        </p:blipFill>
+        <p:spPr>
+          <a:xfrm>
+            <a:off x="4788103" y="2205533"/>
+            <a:ext cx="380390" cy="380390"/>
+          </a:xfrm>
+          <a:prstGeom prst="rect">
+            <a:avLst/>
+          </a:prstGeom>
+        </p:spPr>
+      </p:pic>
+      <p:sp>
+        <p:nvSpPr>
+          <p:cNvPr id="12" name="Text 8"/>
+          <p:cNvSpPr txBox="1"/>
+          <p:nvPr/>
+        </p:nvSpPr>
+        <p:spPr>
+          <a:xfrm>
+            <a:off x="5526938" y="2029968"/>
+            <a:ext cx="2097938" cy="731520"/>
+          </a:xfrm>
+          <a:prstGeom prst="rect">
+            <a:avLst/>
+          </a:prstGeom>
+          <a:noFill/>
+          <a:ln/>
+        </p:spPr>
+        <p:txBody>
+          <a:bodyPr wrap="square" lIns="0" tIns="0" rIns="0" bIns="0" rtlCol="0" anchor="ctr"/>
+          <a:lstStyle/>
+          <a:p>
+            <a:pPr marL="0" indent="0">
+              <a:buNone/>
+            </a:pPr>
+            <a:r>
+              <a:rPr lang="en-US" sz="1700" b="1" dirty="0">
+                <a:solidFill>
+                  <a:srgbClr val="1D2723"/>
+                </a:solidFill>
+                <a:latin typeface="Arial" pitchFamily="34" charset="0"/>
+                <a:ea typeface="Arial" pitchFamily="34" charset="-122"/>
+                <a:cs typeface="Arial" pitchFamily="34" charset="-120"/>
+              </a:rPr>
+              <a:t>Food and beverage manufacturers</a:t>
+            </a:r>
+            <a:endParaRPr lang="en-US" sz="1700" dirty="0"/>
+          </a:p>
+        </p:txBody>
+      </p:sp>
+      <p:sp>
+        <p:nvSpPr>
+          <p:cNvPr id="13" name="Text 9"/>
+          <p:cNvSpPr txBox="1"/>
+          <p:nvPr/>
+        </p:nvSpPr>
+        <p:spPr>
+          <a:xfrm>
+            <a:off x="4612538" y="2926080"/>
+            <a:ext cx="2966618" cy="548640"/>
+          </a:xfrm>
+          <a:prstGeom prst="rect">
+            <a:avLst/>
+          </a:prstGeom>
+          <a:noFill/>
+          <a:ln/>
+        </p:spPr>
+        <p:txBody>
+          <a:bodyPr wrap="square" lIns="0" tIns="0" rIns="0" bIns="0" rtlCol="0" anchor="t"/>
+          <a:lstStyle/>
+          <a:p>
+            <a:pPr marL="0" indent="0">
+              <a:buNone/>
+            </a:pPr>
+            <a:r>
+              <a:rPr lang="en-US" sz="1400" dirty="0">
+                <a:solidFill>
+                  <a:srgbClr val="5E6A64"/>
+                </a:solidFill>
+                <a:latin typeface="Arial" pitchFamily="34" charset="0"/>
+                <a:ea typeface="Arial" pitchFamily="34" charset="-122"/>
+                <a:cs typeface="Arial" pitchFamily="34" charset="-120"/>
+              </a:rPr>
+              <a:t>Procurement costs and hedging</a:t>
+            </a:r>
+            <a:endParaRPr lang="en-US" sz="1400" dirty="0"/>
+          </a:p>
+        </p:txBody>
+      </p:sp>
+      <p:sp>
+        <p:nvSpPr>
+          <p:cNvPr id="14" name="Shape 10"/>
+          <p:cNvSpPr/>
+          <p:nvPr/>
+        </p:nvSpPr>
+        <p:spPr>
+          <a:xfrm>
+            <a:off x="8127797" y="1737360"/>
+            <a:ext cx="3515258" cy="1874520"/>
+          </a:xfrm>
+          <a:prstGeom prst="roundRect">
+            <a:avLst>
+              <a:gd name="adj" fmla="val 3902"/>
+            </a:avLst>
+          </a:prstGeom>
+          <a:solidFill>
+            <a:srgbClr val="F2F5F3"/>
+          </a:solidFill>
+          <a:ln w="9525">
+            <a:solidFill>
+              <a:srgbClr val="F2F5F3"/>
+            </a:solidFill>
+            <a:prstDash val="solid"/>
+          </a:ln>
+        </p:spPr>
+        <p:txBody>
+          <a:bodyPr/>
+          <a:lstStyle/>
+          <a:p>
+            <a:endParaRPr lang="en-US"/>
+          </a:p>
+        </p:txBody>
+      </p:sp>
+      <p:sp>
+        <p:nvSpPr>
+          <p:cNvPr id="15" name="Shape 11"/>
+          <p:cNvSpPr/>
+          <p:nvPr/>
+        </p:nvSpPr>
+        <p:spPr>
+          <a:xfrm>
+            <a:off x="8402117" y="2029968"/>
+            <a:ext cx="731520" cy="731520"/>
+          </a:xfrm>
+          <a:prstGeom prst="ellipse">
+            <a:avLst/>
+          </a:prstGeom>
+          <a:solidFill>
+            <a:srgbClr val="16302A"/>
+          </a:solidFill>
+          <a:ln w="9525">
+            <a:solidFill>
+              <a:srgbClr val="16302A"/>
+            </a:solidFill>
+            <a:prstDash val="solid"/>
+          </a:ln>
+        </p:spPr>
+        <p:txBody>
+          <a:bodyPr/>
+          <a:lstStyle/>
+          <a:p>
+            <a:endParaRPr lang="en-US"/>
+          </a:p>
+        </p:txBody>
+      </p:sp>
+      <p:pic>
+        <p:nvPicPr>
+          <p:cNvPr id="16" name="Image 2" descr="preencoded.png"/>
+          <p:cNvPicPr>
+            <a:picLocks noChangeAspect="1"/>
+          </p:cNvPicPr>
+          <p:nvPr/>
+        </p:nvPicPr>
+        <p:blipFill>
+          <a:blip r:embed="rId5"/>
+          <a:stretch>
+            <a:fillRect/>
+          </a:stretch>
+        </p:blipFill>
+        <p:spPr>
+          <a:xfrm>
+            <a:off x="8577682" y="2205533"/>
+            <a:ext cx="380390" cy="380390"/>
+          </a:xfrm>
+          <a:prstGeom prst="rect">
+            <a:avLst/>
+          </a:prstGeom>
+        </p:spPr>
+      </p:pic>
+      <p:sp>
+        <p:nvSpPr>
+          <p:cNvPr id="17" name="Text 12"/>
+          <p:cNvSpPr txBox="1"/>
+          <p:nvPr/>
+        </p:nvSpPr>
+        <p:spPr>
+          <a:xfrm>
+            <a:off x="9316517" y="2029968"/>
+            <a:ext cx="2097938" cy="731520"/>
+          </a:xfrm>
+          <a:prstGeom prst="rect">
+            <a:avLst/>
+          </a:prstGeom>
+          <a:noFill/>
+          <a:ln/>
+        </p:spPr>
+        <p:txBody>
+          <a:bodyPr wrap="square" lIns="0" tIns="0" rIns="0" bIns="0" rtlCol="0" anchor="ctr"/>
+          <a:lstStyle/>
+          <a:p>
+            <a:pPr marL="0" indent="0">
+              <a:buNone/>
+            </a:pPr>
+            <a:r>
+              <a:rPr lang="en-US" sz="1700" b="1" dirty="0">
+                <a:solidFill>
+                  <a:srgbClr val="1D2723"/>
+                </a:solidFill>
+                <a:latin typeface="Arial" pitchFamily="34" charset="0"/>
+                <a:ea typeface="Arial" pitchFamily="34" charset="-122"/>
+                <a:cs typeface="Arial" pitchFamily="34" charset="-120"/>
+              </a:rPr>
+              <a:t>Agribusiness and logistics</a:t>
+            </a:r>
+            <a:endParaRPr lang="en-US" sz="1700" dirty="0"/>
+          </a:p>
+        </p:txBody>
+      </p:sp>
+      <p:sp>
+        <p:nvSpPr>
+          <p:cNvPr id="18" name="Text 13"/>
+          <p:cNvSpPr txBox="1"/>
+          <p:nvPr/>
+        </p:nvSpPr>
+        <p:spPr>
+          <a:xfrm>
+            <a:off x="8402117" y="2926080"/>
+            <a:ext cx="2966618" cy="548640"/>
+          </a:xfrm>
+          <a:prstGeom prst="rect">
+            <a:avLst/>
+          </a:prstGeom>
+          <a:noFill/>
+          <a:ln/>
+        </p:spPr>
+        <p:txBody>
+          <a:bodyPr wrap="square" lIns="0" tIns="0" rIns="0" bIns="0" rtlCol="0" anchor="t"/>
+          <a:lstStyle/>
+          <a:p>
+            <a:pPr marL="0" indent="0">
+              <a:buNone/>
+            </a:pPr>
+            <a:r>
+              <a:rPr lang="en-US" sz="1400" dirty="0">
+                <a:solidFill>
+                  <a:srgbClr val="5E6A64"/>
+                </a:solidFill>
+                <a:latin typeface="Arial" pitchFamily="34" charset="0"/>
+                <a:ea typeface="Arial" pitchFamily="34" charset="-122"/>
+                <a:cs typeface="Arial" pitchFamily="34" charset="-120"/>
+              </a:rPr>
+              <a:t>Grain handlers, barge and rail operators, ports</a:t>
+            </a:r>
+            <a:endParaRPr lang="en-US" sz="1400" dirty="0"/>
+          </a:p>
+        </p:txBody>
+      </p:sp>
+      <p:sp>
+        <p:nvSpPr>
+          <p:cNvPr id="19" name="Shape 14"/>
+          <p:cNvSpPr/>
+          <p:nvPr/>
+        </p:nvSpPr>
+        <p:spPr>
+          <a:xfrm>
+            <a:off x="548640" y="3886200"/>
+            <a:ext cx="3515258" cy="1874520"/>
+          </a:xfrm>
+          <a:prstGeom prst="roundRect">
+            <a:avLst>
+              <a:gd name="adj" fmla="val 3902"/>
+            </a:avLst>
+          </a:prstGeom>
+          <a:solidFill>
+            <a:srgbClr val="F2F5F3"/>
+          </a:solidFill>
+          <a:ln w="9525">
+            <a:solidFill>
+              <a:srgbClr val="F2F5F3"/>
+            </a:solidFill>
+            <a:prstDash val="solid"/>
+          </a:ln>
+        </p:spPr>
+        <p:txBody>
+          <a:bodyPr/>
+          <a:lstStyle/>
+          <a:p>
+            <a:endParaRPr lang="en-US"/>
+          </a:p>
+        </p:txBody>
+      </p:sp>
+      <p:sp>
+        <p:nvSpPr>
+          <p:cNvPr id="20" name="Shape 15"/>
+          <p:cNvSpPr/>
+          <p:nvPr/>
+        </p:nvSpPr>
+        <p:spPr>
+          <a:xfrm>
+            <a:off x="822960" y="4178808"/>
+            <a:ext cx="731520" cy="731520"/>
+          </a:xfrm>
+          <a:prstGeom prst="ellipse">
+            <a:avLst/>
+          </a:prstGeom>
+          <a:solidFill>
+            <a:srgbClr val="16302A"/>
+          </a:solidFill>
+          <a:ln w="9525">
+            <a:solidFill>
+              <a:srgbClr val="16302A"/>
+            </a:solidFill>
+            <a:prstDash val="solid"/>
+          </a:ln>
+        </p:spPr>
+        <p:txBody>
+          <a:bodyPr/>
+          <a:lstStyle/>
+          <a:p>
+            <a:endParaRPr lang="en-US"/>
+          </a:p>
+        </p:txBody>
+      </p:sp>
+      <p:pic>
+        <p:nvPicPr>
+          <p:cNvPr id="21" name="Image 3" descr="preencoded.png"/>
+          <p:cNvPicPr>
+            <a:picLocks noChangeAspect="1"/>
+          </p:cNvPicPr>
+          <p:nvPr/>
+        </p:nvPicPr>
+        <p:blipFill>
+          <a:blip r:embed="rId6"/>
+          <a:stretch>
+            <a:fillRect/>
+          </a:stretch>
+        </p:blipFill>
+        <p:spPr>
+          <a:xfrm>
+            <a:off x="998525" y="4354373"/>
+            <a:ext cx="380390" cy="380390"/>
+          </a:xfrm>
+          <a:prstGeom prst="rect">
+            <a:avLst/>
+          </a:prstGeom>
+        </p:spPr>
+      </p:pic>
+      <p:sp>
+        <p:nvSpPr>
+          <p:cNvPr id="22" name="Text 16"/>
+          <p:cNvSpPr txBox="1"/>
+          <p:nvPr/>
+        </p:nvSpPr>
+        <p:spPr>
+          <a:xfrm>
+            <a:off x="1737360" y="4178808"/>
+            <a:ext cx="2097938" cy="731520"/>
+          </a:xfrm>
+          <a:prstGeom prst="rect">
+            <a:avLst/>
+          </a:prstGeom>
+          <a:noFill/>
+          <a:ln/>
+        </p:spPr>
+        <p:txBody>
+          <a:bodyPr wrap="square" lIns="0" tIns="0" rIns="0" bIns="0" rtlCol="0" anchor="ctr"/>
+          <a:lstStyle/>
+          <a:p>
+            <a:pPr marL="0" indent="0">
+              <a:buNone/>
+            </a:pPr>
+            <a:r>
+              <a:rPr lang="en-US" sz="1700" b="1" dirty="0">
+                <a:solidFill>
+                  <a:srgbClr val="1D2723"/>
+                </a:solidFill>
+                <a:latin typeface="Arial" pitchFamily="34" charset="0"/>
+                <a:ea typeface="Arial" pitchFamily="34" charset="-122"/>
+                <a:cs typeface="Arial" pitchFamily="34" charset="-120"/>
+              </a:rPr>
+              <a:t>Farmers and cooperatives</a:t>
+            </a:r>
+            <a:endParaRPr lang="en-US" sz="1700" dirty="0"/>
+          </a:p>
+        </p:txBody>
+      </p:sp>
+      <p:sp>
+        <p:nvSpPr>
+          <p:cNvPr id="23" name="Text 17"/>
+          <p:cNvSpPr txBox="1"/>
+          <p:nvPr/>
+        </p:nvSpPr>
+        <p:spPr>
+          <a:xfrm>
+            <a:off x="822960" y="5074920"/>
+            <a:ext cx="2966618" cy="548640"/>
+          </a:xfrm>
+          <a:prstGeom prst="rect">
+            <a:avLst/>
+          </a:prstGeom>
+          <a:noFill/>
+          <a:ln/>
+        </p:spPr>
+        <p:txBody>
+          <a:bodyPr wrap="square" lIns="0" tIns="0" rIns="0" bIns="0" rtlCol="0" anchor="t"/>
+          <a:lstStyle/>
+          <a:p>
+            <a:pPr marL="0" indent="0">
+              <a:buNone/>
+            </a:pPr>
+            <a:r>
+              <a:rPr lang="en-US" sz="1400" dirty="0">
+                <a:solidFill>
+                  <a:srgbClr val="5E6A64"/>
+                </a:solidFill>
+                <a:latin typeface="Arial" pitchFamily="34" charset="0"/>
+                <a:ea typeface="Arial" pitchFamily="34" charset="-122"/>
+                <a:cs typeface="Arial" pitchFamily="34" charset="-120"/>
+              </a:rPr>
+              <a:t>Hedging and marketing decisions</a:t>
+            </a:r>
+            <a:endParaRPr lang="en-US" sz="1400" dirty="0"/>
+          </a:p>
+        </p:txBody>
+      </p:sp>
+      <p:sp>
+        <p:nvSpPr>
+          <p:cNvPr id="24" name="Shape 18"/>
+          <p:cNvSpPr/>
+          <p:nvPr/>
+        </p:nvSpPr>
+        <p:spPr>
+          <a:xfrm>
+            <a:off x="4338218" y="3886200"/>
+            <a:ext cx="3515258" cy="1874520"/>
+          </a:xfrm>
+          <a:prstGeom prst="roundRect">
+            <a:avLst>
+              <a:gd name="adj" fmla="val 3902"/>
+            </a:avLst>
+          </a:prstGeom>
+          <a:solidFill>
+            <a:srgbClr val="F2F5F3"/>
+          </a:solidFill>
+          <a:ln w="9525">
+            <a:solidFill>
+              <a:srgbClr val="F2F5F3"/>
+            </a:solidFill>
+            <a:prstDash val="solid"/>
+          </a:ln>
+        </p:spPr>
+        <p:txBody>
+          <a:bodyPr/>
+          <a:lstStyle/>
+          <a:p>
+            <a:endParaRPr lang="en-US"/>
+          </a:p>
+        </p:txBody>
+      </p:sp>
+      <p:sp>
+        <p:nvSpPr>
+          <p:cNvPr id="25" name="Shape 19"/>
+          <p:cNvSpPr/>
+          <p:nvPr/>
+        </p:nvSpPr>
+        <p:spPr>
+          <a:xfrm>
+            <a:off x="4612538" y="4178808"/>
+            <a:ext cx="731520" cy="731520"/>
+          </a:xfrm>
+          <a:prstGeom prst="ellipse">
+            <a:avLst/>
+          </a:prstGeom>
+          <a:solidFill>
+            <a:srgbClr val="16302A"/>
+          </a:solidFill>
+          <a:ln w="9525">
+            <a:solidFill>
+              <a:srgbClr val="16302A"/>
+            </a:solidFill>
+            <a:prstDash val="solid"/>
+          </a:ln>
+        </p:spPr>
+        <p:txBody>
+          <a:bodyPr/>
+          <a:lstStyle/>
+          <a:p>
+            <a:endParaRPr lang="en-US"/>
+          </a:p>
+        </p:txBody>
+      </p:sp>
+      <p:pic>
+        <p:nvPicPr>
+          <p:cNvPr id="26" name="Image 4" descr="preencoded.png"/>
+          <p:cNvPicPr>
+            <a:picLocks noChangeAspect="1"/>
+          </p:cNvPicPr>
+          <p:nvPr/>
+        </p:nvPicPr>
+        <p:blipFill>
+          <a:blip r:embed="rId7"/>
+          <a:stretch>
+            <a:fillRect/>
+          </a:stretch>
+        </p:blipFill>
+        <p:spPr>
+          <a:xfrm>
+            <a:off x="4788103" y="4354373"/>
+            <a:ext cx="380390" cy="380390"/>
+          </a:xfrm>
+          <a:prstGeom prst="rect">
+            <a:avLst/>
+          </a:prstGeom>
+        </p:spPr>
+      </p:pic>
+      <p:sp>
+        <p:nvSpPr>
+          <p:cNvPr id="27" name="Text 20"/>
+          <p:cNvSpPr txBox="1"/>
+          <p:nvPr/>
+        </p:nvSpPr>
+        <p:spPr>
+          <a:xfrm>
+            <a:off x="5526938" y="4178808"/>
+            <a:ext cx="2097938" cy="731520"/>
+          </a:xfrm>
+          <a:prstGeom prst="rect">
+            <a:avLst/>
+          </a:prstGeom>
+          <a:noFill/>
+          <a:ln/>
+        </p:spPr>
+        <p:txBody>
+          <a:bodyPr wrap="square" lIns="0" tIns="0" rIns="0" bIns="0" rtlCol="0" anchor="ctr"/>
+          <a:lstStyle/>
+          <a:p>
+            <a:pPr marL="0" indent="0">
+              <a:buNone/>
+            </a:pPr>
+            <a:r>
+              <a:rPr lang="en-US" sz="1700" b="1" dirty="0">
+                <a:solidFill>
+                  <a:srgbClr val="1D2723"/>
+                </a:solidFill>
+                <a:latin typeface="Arial" pitchFamily="34" charset="0"/>
+                <a:ea typeface="Arial" pitchFamily="34" charset="-122"/>
+                <a:cs typeface="Arial" pitchFamily="34" charset="-120"/>
+              </a:rPr>
+              <a:t>Insurers and lenders</a:t>
+            </a:r>
+            <a:endParaRPr lang="en-US" sz="1700" dirty="0"/>
+          </a:p>
+        </p:txBody>
+      </p:sp>
+      <p:sp>
+        <p:nvSpPr>
+          <p:cNvPr id="28" name="Text 21"/>
+          <p:cNvSpPr txBox="1"/>
+          <p:nvPr/>
+        </p:nvSpPr>
+        <p:spPr>
+          <a:xfrm>
+            <a:off x="4612538" y="5074920"/>
+            <a:ext cx="2966618" cy="548640"/>
+          </a:xfrm>
+          <a:prstGeom prst="rect">
+            <a:avLst/>
+          </a:prstGeom>
+          <a:noFill/>
+          <a:ln/>
+        </p:spPr>
+        <p:txBody>
+          <a:bodyPr wrap="square" lIns="0" tIns="0" rIns="0" bIns="0" rtlCol="0" anchor="t"/>
+          <a:lstStyle/>
+          <a:p>
+            <a:pPr marL="0" indent="0">
+              <a:buNone/>
+            </a:pPr>
+            <a:r>
+              <a:rPr lang="en-US" sz="1400" dirty="0">
+                <a:solidFill>
+                  <a:srgbClr val="5E6A64"/>
+                </a:solidFill>
+                <a:latin typeface="Arial" pitchFamily="34" charset="0"/>
+                <a:ea typeface="Arial" pitchFamily="34" charset="-122"/>
+                <a:cs typeface="Arial" pitchFamily="34" charset="-120"/>
+              </a:rPr>
+              <a:t>Crop insurance and agricultural credit risk</a:t>
+            </a:r>
+            <a:endParaRPr lang="en-US" sz="1400" dirty="0"/>
+          </a:p>
+        </p:txBody>
+      </p:sp>
+      <p:sp>
+        <p:nvSpPr>
+          <p:cNvPr id="29" name="Shape 22"/>
+          <p:cNvSpPr/>
+          <p:nvPr/>
+        </p:nvSpPr>
+        <p:spPr>
+          <a:xfrm>
+            <a:off x="8127797" y="3886200"/>
+            <a:ext cx="3515258" cy="1874520"/>
+          </a:xfrm>
+          <a:prstGeom prst="roundRect">
+            <a:avLst>
+              <a:gd name="adj" fmla="val 3902"/>
+            </a:avLst>
+          </a:prstGeom>
+          <a:solidFill>
+            <a:srgbClr val="F2F5F3"/>
+          </a:solidFill>
+          <a:ln w="9525">
+            <a:solidFill>
+              <a:srgbClr val="F2F5F3"/>
+            </a:solidFill>
+            <a:prstDash val="solid"/>
+          </a:ln>
+        </p:spPr>
+        <p:txBody>
+          <a:bodyPr/>
+          <a:lstStyle/>
+          <a:p>
+            <a:endParaRPr lang="en-US"/>
+          </a:p>
+        </p:txBody>
+      </p:sp>
+      <p:sp>
+        <p:nvSpPr>
+          <p:cNvPr id="30" name="Shape 23"/>
+          <p:cNvSpPr/>
+          <p:nvPr/>
+        </p:nvSpPr>
+        <p:spPr>
+          <a:xfrm>
+            <a:off x="8402117" y="4178808"/>
+            <a:ext cx="731520" cy="731520"/>
+          </a:xfrm>
+          <a:prstGeom prst="ellipse">
+            <a:avLst/>
+          </a:prstGeom>
+          <a:solidFill>
+            <a:srgbClr val="16302A"/>
+          </a:solidFill>
+          <a:ln w="9525">
+            <a:solidFill>
+              <a:srgbClr val="16302A"/>
+            </a:solidFill>
+            <a:prstDash val="solid"/>
+          </a:ln>
+        </p:spPr>
+        <p:txBody>
+          <a:bodyPr/>
+          <a:lstStyle/>
+          <a:p>
+            <a:endParaRPr lang="en-US"/>
+          </a:p>
+        </p:txBody>
+      </p:sp>
+      <p:pic>
+        <p:nvPicPr>
+          <p:cNvPr id="31" name="Image 5" descr="preencoded.png"/>
+          <p:cNvPicPr>
+            <a:picLocks noChangeAspect="1"/>
+          </p:cNvPicPr>
+          <p:nvPr/>
+        </p:nvPicPr>
+        <p:blipFill>
+          <a:blip r:embed="rId8"/>
+          <a:stretch>
+            <a:fillRect/>
+          </a:stretch>
+        </p:blipFill>
+        <p:spPr>
+          <a:xfrm>
+            <a:off x="8577682" y="4354373"/>
+            <a:ext cx="380390" cy="380390"/>
+          </a:xfrm>
+          <a:prstGeom prst="rect">
+            <a:avLst/>
+          </a:prstGeom>
+        </p:spPr>
+      </p:pic>
+      <p:sp>
+        <p:nvSpPr>
+          <p:cNvPr id="32" name="Text 24"/>
+          <p:cNvSpPr txBox="1"/>
+          <p:nvPr/>
+        </p:nvSpPr>
+        <p:spPr>
+          <a:xfrm>
+            <a:off x="9316517" y="4178808"/>
+            <a:ext cx="2097938" cy="731520"/>
+          </a:xfrm>
+          <a:prstGeom prst="rect">
+            <a:avLst/>
+          </a:prstGeom>
+          <a:noFill/>
+          <a:ln/>
+        </p:spPr>
+        <p:txBody>
+          <a:bodyPr wrap="square" lIns="0" tIns="0" rIns="0" bIns="0" rtlCol="0" anchor="ctr"/>
+          <a:lstStyle/>
+          <a:p>
+            <a:pPr marL="0" indent="0">
+              <a:buNone/>
+            </a:pPr>
+            <a:r>
+              <a:rPr lang="en-US" sz="1700" b="1" dirty="0">
+                <a:solidFill>
+                  <a:srgbClr val="1D2723"/>
+                </a:solidFill>
+                <a:latin typeface="Arial" pitchFamily="34" charset="0"/>
+                <a:ea typeface="Arial" pitchFamily="34" charset="-122"/>
+                <a:cs typeface="Arial" pitchFamily="34" charset="-120"/>
+              </a:rPr>
+              <a:t>Policymakers and consumers</a:t>
+            </a:r>
+            <a:endParaRPr lang="en-US" sz="1700" dirty="0"/>
+          </a:p>
+        </p:txBody>
+      </p:sp>
+      <p:sp>
+        <p:nvSpPr>
+          <p:cNvPr id="33" name="Text 25"/>
+          <p:cNvSpPr txBox="1"/>
+          <p:nvPr/>
+        </p:nvSpPr>
+        <p:spPr>
+          <a:xfrm>
+            <a:off x="8402117" y="5074920"/>
+            <a:ext cx="2966618" cy="548640"/>
+          </a:xfrm>
+          <a:prstGeom prst="rect">
+            <a:avLst/>
+          </a:prstGeom>
+          <a:noFill/>
+          <a:ln/>
+        </p:spPr>
+        <p:txBody>
+          <a:bodyPr wrap="square" lIns="0" tIns="0" rIns="0" bIns="0" rtlCol="0" anchor="t"/>
+          <a:lstStyle/>
+          <a:p>
+            <a:pPr marL="0" indent="0">
+              <a:buNone/>
+            </a:pPr>
+            <a:r>
+              <a:rPr lang="en-US" sz="1400" dirty="0">
+                <a:solidFill>
+                  <a:srgbClr val="5E6A64"/>
+                </a:solidFill>
+                <a:latin typeface="Arial" pitchFamily="34" charset="0"/>
+                <a:ea typeface="Arial" pitchFamily="34" charset="-122"/>
+                <a:cs typeface="Arial" pitchFamily="34" charset="-120"/>
+              </a:rPr>
+              <a:t>Food security and food prices</a:t>
+            </a:r>
+            <a:endParaRPr lang="en-US" sz="1400" dirty="0"/>
+          </a:p>
+        </p:txBody>
+      </p:sp>
+      <p:sp>
+        <p:nvSpPr>
+          <p:cNvPr id="34" name="Text 26"/>
+          <p:cNvSpPr txBox="1"/>
+          <p:nvPr/>
+        </p:nvSpPr>
+        <p:spPr>
+          <a:xfrm>
+            <a:off x="548640" y="5870448"/>
+            <a:ext cx="10424160" cy="365760"/>
+          </a:xfrm>
+          <a:prstGeom prst="rect">
+            <a:avLst/>
+          </a:prstGeom>
+          <a:noFill/>
+          <a:ln/>
+        </p:spPr>
+        <p:txBody>
+          <a:bodyPr wrap="square" lIns="0" tIns="0" rIns="0" bIns="0" rtlCol="0" anchor="ctr"/>
+          <a:lstStyle/>
+          <a:p>
+            <a:pPr marL="0" indent="0">
+              <a:buNone/>
+            </a:pPr>
+            <a:r>
+              <a:rPr lang="en-US" sz="1500" i="1" dirty="0">
+                <a:solidFill>
+                  <a:srgbClr val="2E6B4F"/>
+                </a:solidFill>
+                <a:latin typeface="Arial" pitchFamily="34" charset="0"/>
+                <a:ea typeface="Arial" pitchFamily="34" charset="-122"/>
+                <a:cs typeface="Arial" pitchFamily="34" charset="-120"/>
+              </a:rPr>
+              <a:t>Even if traders already price the weather, a validated risk score helps everyone who does not trade.</a:t>
+            </a:r>
+            <a:endParaRPr lang="en-US" sz="1500" dirty="0"/>
+          </a:p>
+        </p:txBody>
+      </p:sp>
+      <p:sp>
+        <p:nvSpPr>
+          <p:cNvPr id="35" name="Slide Number Placeholder 0"/>
           <p:cNvSpPr>
             <a:spLocks noGrp="1"/>
           </p:cNvSpPr>

</xml_diff>